<commit_message>
Point GitLab prompts at gitlab.ciklum.net
The setup prompt signs glab in to gitlab.ciklum.net alongside any existing
GitLab sign-ins and names that host in every glab command; the prepare and
verify prompts, kit READMEs, Session 01 page and deck name the host too.
Guides and LEARNER_PROMPTS.md regenerated; check.py passes.

Co-Authored-By: Claude Opus 5.5 <noreply@anthropic.com>
Claude-Session: https://claude.ai/code/session_0123W63ZaDAAnYHCFqarTnbL
</commit_message>
<xml_diff>
--- a/L3 2026 Agentic Platform Instructor Materials/slides/01 Agent architecture and the ReAct runtime.pptx
+++ b/L3 2026 Agentic Platform Instructor Materials/slides/01 Agent architecture and the ReAct runtime.pptx
@@ -2146,7 +2146,7 @@
           <a:lstStyle/>
           <a:p>
             <a:r>
-              <a:t>Create an empty folder such as ~/agentic-course, start your coding agent in it, and paste the lesson-00 prompt from the session page. It clones the public course repository as a read-only copy, creates your project from the kit's starter, installs everything, runs the first test, installs glab, signs you in to GitLab and pushes your project to a new private repository in the course group. Start your agent in the same folder every later session.</a:t>
+              <a:t>Create an empty folder such as ~/agentic-course, start your coding agent in it, and paste the lesson-00 prompt from the session page. It clones the public course repository as a read-only copy, creates your project from the kit's starter, installs everything, runs the first test, installs glab, signs you in to gitlab.ciklum.net (keeping any other GitLab sign-ins) and pushes your project to a new private repository in the course group there. Start your agent in the same folder every later session.</a:t>
             </a:r>
           </a:p>
         </p:txBody>
@@ -19659,7 +19659,7 @@
                 </a:solidFill>
                 <a:latin typeface="Zalando Sans Light"/>
               </a:rPr>
-              <a:t>1 passed · LESSON = 0 · your project in your GitLab group</a:t>
+              <a:t>1 passed · LESSON = 0 · your project on gitlab.ciklum.net</a:t>
             </a:r>
           </a:p>
         </p:txBody>

</xml_diff>

<commit_message>
Session 01: name the owners platform, runtime and model
The ownership table said "application", while the course frames the parts
as platform, runtime and model. The platform sets identity, permissions and
limits (until Session 08 the code that starts the run plays it), the runtime
enforces them and records events, and the model only proposes. Page, deck
and guide 01 updated.

Co-Authored-By: Claude Opus 5.5 <noreply@anthropic.com>
Claude-Session: https://claude.ai/code/session_0123W63ZaDAAnYHCFqarTnbL
</commit_message>
<xml_diff>
--- a/L3 2026 Agentic Platform Instructor Materials/slides/01 Agent architecture and the ReAct runtime.pptx
+++ b/L3 2026 Agentic Platform Instructor Materials/slides/01 Agent architecture and the ReAct runtime.pptx
@@ -1972,7 +1972,7 @@
           <a:lstStyle/>
           <a:p>
             <a:r>
-              <a:t>The model owns nothing. Tenant, run, role, permitted tools and limits are set by application code; model output is untrusted input that the runtime validates before acting on it. Events record what happened step by step; later the console shows them as a run timeline.</a:t>
+              <a:t>The platform sets who a run is for, what it may use and how far it may go. Until Session 08 the code that starts the run plays the platform: today the lab or a test; from Session 08, Platform.submit. The runtime, core.py, enforces the limits and validates model output, which is untrusted input, before acting on it. Events record what happened step by step; later the console shows them as a run timeline.</a:t>
             </a:r>
           </a:p>
         </p:txBody>
@@ -2204,7 +2204,7 @@
           <a:lstStyle/>
           <a:p>
             <a:r>
-              <a:t>core.py is the agent runtime: the core of every agent you will run. It holds the data the application owns, the shape of a model's reply and of a run, and the ReAct loop. From Session 08 the platform hosts it; a supervisor built from the same loop coordinates other agents from Session 06. The given files are data and a scripted mock model everyone shares. In production agents run in separate processes or sandboxes, apart from the platform's control plane; in this course they run in the platform's own process, a compromise that keeps everything runnable on a laptop.</a:t>
+              <a:t>core.py is the agent runtime: the core of every agent you will run. It holds the data the platform sets, the shape of a model's reply and of a run, and the ReAct loop. From Session 08 the platform hosts it; a supervisor built from the same loop coordinates other agents from Session 06. The given files are data and a scripted mock model everyone shares. In production agents run in separate processes or sandboxes, apart from the platform's control plane; in this course they run in the platform's own process, a compromise that keeps everything runnable on a laptop.</a:t>
             </a:r>
           </a:p>
         </p:txBody>
@@ -2262,7 +2262,7 @@
           <a:lstStyle/>
           <a:p>
             <a:r>
-              <a:t>Step 1 creates core.py with the data contracts only: Context, Limits, Reply and Run. Separate what the application owns from what the model produces. None of these fields come from the model. Ask: why not let the model's answer say which tools it may use? Because model output is untrusted; the application builds Context.</a:t>
+              <a:t>Step 1 creates core.py with the data contracts only: Context, Limits, Reply and Run. Separate what the platform sets from what the model produces. None of these fields come from the model. Ask: why not let the model's answer say which tools it may use? Because model output is untrusted; the platform builds Context.</a:t>
             </a:r>
           </a:p>
         </p:txBody>
@@ -16844,7 +16844,7 @@
           <a:lstStyle/>
           <a:p>
             <a:r>
-              <a:t>The application owns the limits</a:t>
+              <a:t>Platform, runtime, model</a:t>
             </a:r>
           </a:p>
         </p:txBody>
@@ -16905,7 +16905,7 @@
                           </a:solidFill>
                           <a:latin typeface="Zalando Sans Medium"/>
                         </a:rPr>
-                        <a:t>Owner</a:t>
+                        <a:t>Set by</a:t>
                       </a:r>
                     </a:p>
                   </a:txBody>
@@ -16973,7 +16973,7 @@
                           </a:solidFill>
                           <a:latin typeface="Zalando Sans Light"/>
                         </a:rPr>
-                        <a:t>application</a:t>
+                        <a:t>platform</a:t>
                       </a:r>
                     </a:p>
                   </a:txBody>
@@ -17041,7 +17041,7 @@
                           </a:solidFill>
                           <a:latin typeface="Zalando Sans Light"/>
                         </a:rPr>
-                        <a:t>application</a:t>
+                        <a:t>platform</a:t>
                       </a:r>
                     </a:p>
                   </a:txBody>
@@ -17109,7 +17109,7 @@
                           </a:solidFill>
                           <a:latin typeface="Zalando Sans Light"/>
                         </a:rPr>
-                        <a:t>application</a:t>
+                        <a:t>platform</a:t>
                       </a:r>
                     </a:p>
                   </a:txBody>
@@ -17131,7 +17131,7 @@
                           </a:solidFill>
                           <a:latin typeface="Zalando Sans Light"/>
                         </a:rPr>
-                        <a:t>Each limit catches a different failure; together they bound every run</a:t>
+                        <a:t>Each limit catches a different failure; the runtime enforces them</a:t>
                       </a:r>
                     </a:p>
                   </a:txBody>
@@ -17316,7 +17316,7 @@
                 </a:solidFill>
                 <a:latin typeface="Zalando Sans Medium"/>
               </a:rPr>
-              <a:t>The model owns nothing.</a:t>
+              <a:t>The platform sets. The runtime enforces. The model owns nothing.</a:t>
             </a:r>
           </a:p>
         </p:txBody>
@@ -20267,7 +20267,7 @@
                 </a:solidFill>
                 <a:latin typeface="Zalando Sans Light"/>
               </a:rPr>
-              <a:t>The data the application owns, the shape of a model's reply and of a run, and the ReAct loop. Every later session builds on it.</a:t>
+              <a:t>The data the platform sets, the shape of a model's reply and of a run, and the ReAct loop. Every later session builds on it.</a:t>
             </a:r>
           </a:p>
           <a:p>
@@ -24132,7 +24132,7 @@
                 </a:solidFill>
                 <a:latin typeface="Zalando Sans Light"/>
               </a:rPr>
-              <a:t>tenant, role and permitted tools are set by the application, never by model output.</a:t>
+              <a:t>tenant, role and permitted tools are set by the platform, never by model output.</a:t>
             </a:r>
           </a:p>
         </p:txBody>

</xml_diff>

<commit_message>
Keep Session 01 on incident/; move the project in a Lesson 02 prompt
lesson-00 and lesson-01 go back to their incident/ commits, and every Session 01
prompt, page, deck slide, guide and content document is as it was before the
restructure. Lesson 02 now starts with one extra prompt, "Move to the course
layout", that moves a learner's project into agent_runtime/ and course/ (still
7 passed) before the check pack adds the platform in agentic_platform/.

The guide builder supports the optional layout_prompt (Lesson 02 has 14 prompts),
and the kit maps given files and checks to the incident/ layout for Lesson 01.

Co-Authored-By: Claude Opus 5.5 <noreply@anthropic.com>
Claude-Session: https://claude.ai/code/session_0123W63ZaDAAnYHCFqarTnbL
</commit_message>
<xml_diff>
--- a/L3 2026 Agentic Platform Instructor Materials/slides/01 Agent architecture and the ReAct runtime.pptx
+++ b/L3 2026 Agentic Platform Instructor Materials/slides/01 Agent architecture and the ReAct runtime.pptx
@@ -2204,7 +2204,7 @@
           <a:lstStyle/>
           <a:p>
             <a:r>
-              <a:t>agent_runtime/core.py is the agent runtime: the core of every agent you will run. It holds the data the platform sets, the shape of a model's reply and of a run, and the ReAct loop. From Session 08 the platform hosts it; a supervisor built from the same loop coordinates other agents from Session 06. The given files are data and a scripted mock model everyone shares. In production agents run in separate processes or sandboxes, apart from the platform's control plane; in this course they run in the platform's own process, a compromise that keeps everything runnable on a laptop.</a:t>
+              <a:t>core.py is the agent runtime: the core of every agent you will run. It holds the data the platform sets, the shape of a model's reply and of a run, and the ReAct loop. From Session 08 the platform hosts it; a supervisor built from the same loop coordinates other agents from Session 06. The given files are data and a scripted mock model everyone shares. In production agents run in separate processes or sandboxes, apart from the platform's control plane; in this course they run in the platform's own process, a compromise that keeps everything runnable on a laptop.</a:t>
             </a:r>
           </a:p>
         </p:txBody>
@@ -20041,7 +20041,7 @@
                 </a:solidFill>
                 <a:latin typeface="IBM Plex Mono"/>
               </a:rPr>
-              <a:t>  agent_runtime/    the agent runtime</a:t>
+              <a:t>  incident/</a:t>
             </a:r>
           </a:p>
           <a:p>
@@ -20056,11 +20056,11 @@
             <a:r>
               <a:rPr sz="1000">
                 <a:solidFill>
-                  <a:srgbClr val="00FFBE"/>
+                  <a:srgbClr val="E6ECF5"/>
                 </a:solidFill>
                 <a:latin typeface="IBM Plex Mono"/>
               </a:rPr>
-              <a:t>    core.py       you build: the runtime</a:t>
+              <a:t>    __init__.py   LESSON = 0, then 1</a:t>
             </a:r>
           </a:p>
           <a:p>
@@ -20075,11 +20075,11 @@
             <a:r>
               <a:rPr sz="1000">
                 <a:solidFill>
-                  <a:srgbClr val="00FFBE"/>
+                  <a:srgbClr val="E6ECF5"/>
                 </a:solidFill>
                 <a:latin typeface="IBM Plex Mono"/>
               </a:rPr>
-              <a:t>    providers.py  you build; mock is given</a:t>
+              <a:t>    lab.py        runs a session's demo</a:t>
             </a:r>
           </a:p>
           <a:p>
@@ -20094,11 +20094,11 @@
             <a:r>
               <a:rPr sz="1000">
                 <a:solidFill>
-                  <a:srgbClr val="E6ECF5"/>
+                  <a:srgbClr val="00FFBE"/>
                 </a:solidFill>
                 <a:latin typeface="IBM Plex Mono"/>
               </a:rPr>
-              <a:t>  course/           course scaffolding</a:t>
+              <a:t>    core.py       you build: the runtime</a:t>
             </a:r>
           </a:p>
           <a:p>
@@ -20113,11 +20113,11 @@
             <a:r>
               <a:rPr sz="1000">
                 <a:solidFill>
-                  <a:srgbClr val="E6ECF5"/>
+                  <a:srgbClr val="00FFBE"/>
                 </a:solidFill>
                 <a:latin typeface="IBM Plex Mono"/>
               </a:rPr>
-              <a:t>    __init__.py   LESSON = 0, then 1</a:t>
+              <a:t>    providers.py  you build; mock is given</a:t>
             </a:r>
           </a:p>
           <a:p>
@@ -20136,7 +20136,7 @@
                 </a:solidFill>
                 <a:latin typeface="IBM Plex Mono"/>
               </a:rPr>
-              <a:t>    lab.py        runs a session's demo</a:t>
+              <a:t>    fixtures.py   given: synthetic data</a:t>
             </a:r>
           </a:p>
           <a:p>
@@ -20155,7 +20155,7 @@
                 </a:solidFill>
                 <a:latin typeface="IBM Plex Mono"/>
               </a:rPr>
-              <a:t>    fixtures.py   given: synthetic data</a:t>
+              <a:t>    labs/l01.py   check pack: the demo</a:t>
             </a:r>
           </a:p>
           <a:p>
@@ -20174,7 +20174,7 @@
                 </a:solidFill>
                 <a:latin typeface="IBM Plex Mono"/>
               </a:rPr>
-              <a:t>    labs/l01.py   check pack: the demo</a:t>
+              <a:t>  tests/</a:t>
             </a:r>
           </a:p>
           <a:p>
@@ -20193,7 +20193,7 @@
                 </a:solidFill>
                 <a:latin typeface="IBM Plex Mono"/>
               </a:rPr>
-              <a:t>  tests/</a:t>
+              <a:t>    test_setup.py</a:t>
             </a:r>
           </a:p>
           <a:p>
@@ -20212,45 +20212,7 @@
                 </a:solidFill>
                 <a:latin typeface="IBM Plex Mono"/>
               </a:rPr>
-              <a:t>    test_setup.py</a:t>
-            </a:r>
-          </a:p>
-          <a:p>
-            <a:pPr algn="l">
-              <a:lnSpc>
-                <a:spcPct val="100000"/>
-              </a:lnSpc>
-              <a:spcAft>
-                <a:spcPts val="0"/>
-              </a:spcAft>
-            </a:pPr>
-            <a:r>
-              <a:rPr sz="1000">
-                <a:solidFill>
-                  <a:srgbClr val="E6ECF5"/>
-                </a:solidFill>
-                <a:latin typeface="IBM Plex Mono"/>
-              </a:rPr>
               <a:t>    test_lesson01.py  check pack</a:t>
-            </a:r>
-          </a:p>
-          <a:p>
-            <a:pPr algn="l">
-              <a:lnSpc>
-                <a:spcPct val="100000"/>
-              </a:lnSpc>
-              <a:spcAft>
-                <a:spcPts val="0"/>
-              </a:spcAft>
-            </a:pPr>
-            <a:r>
-              <a:rPr sz="1000">
-                <a:solidFill>
-                  <a:srgbClr val="E6ECF5"/>
-                </a:solidFill>
-                <a:latin typeface="IBM Plex Mono"/>
-              </a:rPr>
-              <a:t>  agentic_platform/ arrives in Session 02</a:t>
             </a:r>
           </a:p>
         </p:txBody>

</xml_diff>